<commit_message>
Substrate tunnelling booked to the substrate channel: Fig. 2(d)-(f) above n_sub 1.8 and Table 1 recomputed; Fig. 5 calculation conditions and deposition details in Methods
Co-Authored-By: Claude Fable 5.1 <noreply@anthropic.com>
Claude-Session: https://claude.ai/code/session_01A1WQ3WGcJw8tT3QK2n57xo
</commit_message>
<xml_diff>
--- a/figures/table1/table1.pptx
+++ b/figures/table1/table1.pptx
@@ -3624,7 +3624,7 @@
                           </a:solidFill>
                           <a:latin typeface="Arial"/>
                         </a:rPr>
-                        <a:t>0.952</a:t>
+                        <a:t>0.963</a:t>
                       </a:r>
                     </a:p>
                   </a:txBody>
@@ -3659,7 +3659,7 @@
                           </a:solidFill>
                           <a:latin typeface="Arial"/>
                         </a:rPr>
-                        <a:t>0.034</a:t>
+                        <a:t>0.023</a:t>
                       </a:r>
                     </a:p>
                   </a:txBody>
@@ -3764,7 +3764,7 @@
                           </a:solidFill>
                           <a:latin typeface="Arial"/>
                         </a:rPr>
-                        <a:t>0.869</a:t>
+                        <a:t>0.878</a:t>
                       </a:r>
                     </a:p>
                   </a:txBody>
@@ -3906,7 +3906,7 @@
                           </a:solidFill>
                           <a:latin typeface="Arial"/>
                         </a:rPr>
-                        <a:t>0.963</a:t>
+                        <a:t>0.971</a:t>
                       </a:r>
                     </a:p>
                   </a:txBody>
@@ -3941,7 +3941,7 @@
                           </a:solidFill>
                           <a:latin typeface="Arial"/>
                         </a:rPr>
-                        <a:t>0.023</a:t>
+                        <a:t>0.015</a:t>
                       </a:r>
                     </a:p>
                   </a:txBody>
@@ -4046,7 +4046,7 @@
                           </a:solidFill>
                           <a:latin typeface="Arial"/>
                         </a:rPr>
-                        <a:t>0.875</a:t>
+                        <a:t>0.882</a:t>
                       </a:r>
                     </a:p>
                   </a:txBody>
@@ -4194,7 +4194,7 @@
                           </a:solidFill>
                           <a:latin typeface="Arial"/>
                         </a:rPr>
-                        <a:t>0.970</a:t>
+                        <a:t>0.976</a:t>
                       </a:r>
                     </a:p>
                   </a:txBody>
@@ -4231,7 +4231,7 @@
                           </a:solidFill>
                           <a:latin typeface="Arial"/>
                         </a:rPr>
-                        <a:t>0.015</a:t>
+                        <a:t>0.010</a:t>
                       </a:r>
                     </a:p>
                   </a:txBody>
@@ -4342,7 +4342,7 @@
                           </a:solidFill>
                           <a:latin typeface="Arial"/>
                         </a:rPr>
-                        <a:t>0.879</a:t>
+                        <a:t>0.884</a:t>
                       </a:r>
                     </a:p>
                   </a:txBody>
@@ -4486,7 +4486,7 @@
                           </a:solidFill>
                           <a:latin typeface="Arial"/>
                         </a:rPr>
-                        <a:t>0.955</a:t>
+                        <a:t>0.966</a:t>
                       </a:r>
                     </a:p>
                   </a:txBody>
@@ -4521,7 +4521,7 @@
                           </a:solidFill>
                           <a:latin typeface="Arial"/>
                         </a:rPr>
-                        <a:t>0.033</a:t>
+                        <a:t>0.023</a:t>
                       </a:r>
                     </a:p>
                   </a:txBody>
@@ -4626,7 +4626,7 @@
                           </a:solidFill>
                           <a:latin typeface="Arial"/>
                         </a:rPr>
-                        <a:t>0.887</a:t>
+                        <a:t>0.897</a:t>
                       </a:r>
                     </a:p>
                   </a:txBody>
@@ -4768,7 +4768,7 @@
                           </a:solidFill>
                           <a:latin typeface="Arial"/>
                         </a:rPr>
-                        <a:t>0.966</a:t>
+                        <a:t>0.973</a:t>
                       </a:r>
                     </a:p>
                   </a:txBody>
@@ -4803,7 +4803,7 @@
                           </a:solidFill>
                           <a:latin typeface="Arial"/>
                         </a:rPr>
-                        <a:t>0.023</a:t>
+                        <a:t>0.015</a:t>
                       </a:r>
                     </a:p>
                   </a:txBody>
@@ -4908,7 +4908,7 @@
                           </a:solidFill>
                           <a:latin typeface="Arial"/>
                         </a:rPr>
-                        <a:t>0.894</a:t>
+                        <a:t>0.902</a:t>
                       </a:r>
                     </a:p>
                   </a:txBody>
@@ -5056,7 +5056,7 @@
                           </a:solidFill>
                           <a:latin typeface="Arial"/>
                         </a:rPr>
-                        <a:t>0.973</a:t>
+                        <a:t>0.979</a:t>
                       </a:r>
                     </a:p>
                   </a:txBody>
@@ -5093,7 +5093,7 @@
                           </a:solidFill>
                           <a:latin typeface="Arial"/>
                         </a:rPr>
-                        <a:t>0.015</a:t>
+                        <a:t>0.010</a:t>
                       </a:r>
                     </a:p>
                   </a:txBody>
@@ -5204,7 +5204,7 @@
                           </a:solidFill>
                           <a:latin typeface="Arial"/>
                         </a:rPr>
-                        <a:t>0.899</a:t>
+                        <a:t>0.905</a:t>
                       </a:r>
                     </a:p>
                   </a:txBody>
@@ -5348,7 +5348,7 @@
                           </a:solidFill>
                           <a:latin typeface="Arial"/>
                         </a:rPr>
-                        <a:t>0.963</a:t>
+                        <a:t>0.981</a:t>
                       </a:r>
                     </a:p>
                   </a:txBody>
@@ -5383,7 +5383,7 @@
                           </a:solidFill>
                           <a:latin typeface="Arial"/>
                         </a:rPr>
-                        <a:t>0.021</a:t>
+                        <a:t>0.003</a:t>
                       </a:r>
                     </a:p>
                   </a:txBody>
@@ -5488,7 +5488,7 @@
                           </a:solidFill>
                           <a:latin typeface="Arial"/>
                         </a:rPr>
-                        <a:t>0.874</a:t>
+                        <a:t>0.890</a:t>
                       </a:r>
                     </a:p>
                   </a:txBody>
@@ -5630,7 +5630,7 @@
                           </a:solidFill>
                           <a:latin typeface="Arial"/>
                         </a:rPr>
-                        <a:t>0.970</a:t>
+                        <a:t>0.981</a:t>
                       </a:r>
                     </a:p>
                   </a:txBody>
@@ -5665,7 +5665,7 @@
                           </a:solidFill>
                           <a:latin typeface="Arial"/>
                         </a:rPr>
-                        <a:t>0.014</a:t>
+                        <a:t>0.002</a:t>
                       </a:r>
                     </a:p>
                   </a:txBody>
@@ -5770,7 +5770,7 @@
                           </a:solidFill>
                           <a:latin typeface="Arial"/>
                         </a:rPr>
-                        <a:t>0.875</a:t>
+                        <a:t>0.886</a:t>
                       </a:r>
                     </a:p>
                   </a:txBody>
@@ -5918,7 +5918,7 @@
                           </a:solidFill>
                           <a:latin typeface="Arial"/>
                         </a:rPr>
-                        <a:t>0.974</a:t>
+                        <a:t>0.982</a:t>
                       </a:r>
                     </a:p>
                   </a:txBody>
@@ -5955,7 +5955,7 @@
                           </a:solidFill>
                           <a:latin typeface="Arial"/>
                         </a:rPr>
-                        <a:t>0.009</a:t>
+                        <a:t>0.001</a:t>
                       </a:r>
                     </a:p>
                   </a:txBody>
@@ -6066,7 +6066,7 @@
                           </a:solidFill>
                           <a:latin typeface="Arial"/>
                         </a:rPr>
-                        <a:t>0.877</a:t>
+                        <a:t>0.883</a:t>
                       </a:r>
                     </a:p>
                   </a:txBody>
@@ -6210,7 +6210,7 @@
                           </a:solidFill>
                           <a:latin typeface="Arial"/>
                         </a:rPr>
-                        <a:t>0.966</a:t>
+                        <a:t>0.984</a:t>
                       </a:r>
                     </a:p>
                   </a:txBody>
@@ -6245,7 +6245,7 @@
                           </a:solidFill>
                           <a:latin typeface="Arial"/>
                         </a:rPr>
-                        <a:t>0.021</a:t>
+                        <a:t>0.003</a:t>
                       </a:r>
                     </a:p>
                   </a:txBody>
@@ -6350,7 +6350,7 @@
                           </a:solidFill>
                           <a:latin typeface="Arial"/>
                         </a:rPr>
-                        <a:t>0.895</a:t>
+                        <a:t>0.912</a:t>
                       </a:r>
                     </a:p>
                   </a:txBody>
@@ -6492,7 +6492,7 @@
                           </a:solidFill>
                           <a:latin typeface="Arial"/>
                         </a:rPr>
-                        <a:t>0.973</a:t>
+                        <a:t>0.984</a:t>
                       </a:r>
                     </a:p>
                   </a:txBody>
@@ -6527,7 +6527,7 @@
                           </a:solidFill>
                           <a:latin typeface="Arial"/>
                         </a:rPr>
-                        <a:t>0.014</a:t>
+                        <a:t>0.002</a:t>
                       </a:r>
                     </a:p>
                   </a:txBody>
@@ -6632,7 +6632,7 @@
                           </a:solidFill>
                           <a:latin typeface="Arial"/>
                         </a:rPr>
-                        <a:t>0.898</a:t>
+                        <a:t>0.909</a:t>
                       </a:r>
                     </a:p>
                   </a:txBody>
@@ -6780,7 +6780,7 @@
                           </a:solidFill>
                           <a:latin typeface="Arial"/>
                         </a:rPr>
-                        <a:t>0.978</a:t>
+                        <a:t>0.985</a:t>
                       </a:r>
                     </a:p>
                   </a:txBody>
@@ -6817,7 +6817,7 @@
                           </a:solidFill>
                           <a:latin typeface="Arial"/>
                         </a:rPr>
-                        <a:t>0.009</a:t>
+                        <a:t>0.001</a:t>
                       </a:r>
                     </a:p>
                   </a:txBody>
@@ -6928,7 +6928,7 @@
                           </a:solidFill>
                           <a:latin typeface="Arial"/>
                         </a:rPr>
-                        <a:t>0.900</a:t>
+                        <a:t>0.907</a:t>
                       </a:r>
                     </a:p>
                   </a:txBody>
@@ -6986,7 +6986,7 @@
                 </a:solidFill>
                 <a:latin typeface="Arial"/>
               </a:rPr>
-              <a:t>회색 행은 흡수가 더 작은 ITO(k = 0.002). SPP 손실은 evanescent 성분 전체(SPP 모드 포함). 식 (3)으로 계산하면 η_ext 0.932–0.945, EQE 0.888–0.924로 급수보다 1.4–2.5 %p 높다(식 (3)은 상한). 원자료: sim/audit/table1_series.csv.</a:t>
+              <a:t>회색 행은 흡수가 더 작은 ITO(k = 0.002). Θ = 0.67은 등방성. SPP 손실은 evanescent 성분 전체(SPP 모드 포함). 식 (3)으로 계산하면 η_ext 0.932–0.945, EQE 0.898–0.931로 급수보다 1.4–3.3 %p 높다(식 (3)은 상한). 원자료: sim/audit/table1_series.csv.</a:t>
             </a:r>
           </a:p>
         </p:txBody>

</xml_diff>

<commit_message>
Table 1 with full-spectrum and 550 nm values; author's model run in Octave with three fixes and compared; author's PDF edits folded into the English draft
Co-Authored-By: Claude Fable 5.1 <noreply@anthropic.com>
Claude-Session: https://claude.ai/code/session_01A1WQ3WGcJw8tT3QK2n57xo
</commit_message>
<xml_diff>
--- a/figures/table1/table1.pptx
+++ b/figures/table1/table1.pptx
@@ -3126,7 +3126,7 @@
                 </a:solidFill>
                 <a:latin typeface="Arial"/>
               </a:rPr>
-              <a:t>실제 재료 스택으로 계산한 near-unity 설계의 EQE (550 nm, PLQY = 1)</a:t>
+              <a:t>실제 재료 스택으로 계산한 near-unity 설계의 EQE (PLQY = 1; 각 칸은 다파장 400–700 nm / 550 nm)</a:t>
             </a:r>
           </a:p>
         </p:txBody>
@@ -3182,14 +3182,14 @@
             <a:tbl>
               <a:tblPr firstRow="0" bandRow="0"/>
               <a:tblGrid>
+                <a:gridCol w="1051560"/>
+                <a:gridCol w="914400"/>
                 <a:gridCol w="1234440"/>
-                <a:gridCol w="1097280"/>
-                <a:gridCol w="1417320"/>
-                <a:gridCol w="1371600"/>
-                <a:gridCol w="1371600"/>
-                <a:gridCol w="1371600"/>
                 <a:gridCol w="1600200"/>
-                <a:gridCol w="1600200"/>
+                <a:gridCol w="1463040"/>
+                <a:gridCol w="914400"/>
+                <a:gridCol w="1920240"/>
+                <a:gridCol w="1965960"/>
               </a:tblGrid>
               <a:tr h="292608">
                 <a:tc>
@@ -3513,7 +3513,7 @@
                     <a:p>
                       <a:pPr algn="ctr"/>
                       <a:r>
-                        <a:rPr sz="1200" b="0">
+                        <a:rPr sz="1100" b="0">
                           <a:solidFill>
                             <a:srgbClr val="000000"/>
                           </a:solidFill>
@@ -3548,7 +3548,7 @@
                     <a:p>
                       <a:pPr algn="ctr"/>
                       <a:r>
-                        <a:rPr sz="1200" b="0">
+                        <a:rPr sz="1100" b="0">
                           <a:solidFill>
                             <a:srgbClr val="000000"/>
                           </a:solidFill>
@@ -3583,7 +3583,7 @@
                     <a:p>
                       <a:pPr algn="ctr"/>
                       <a:r>
-                        <a:rPr sz="1200" b="0">
+                        <a:rPr sz="1100" b="0">
                           <a:solidFill>
                             <a:srgbClr val="000000"/>
                           </a:solidFill>
@@ -3618,13 +3618,13 @@
                     <a:p>
                       <a:pPr algn="ctr"/>
                       <a:r>
-                        <a:rPr sz="1200" b="0">
-                          <a:solidFill>
-                            <a:srgbClr val="000000"/>
-                          </a:solidFill>
-                          <a:latin typeface="Arial"/>
-                        </a:rPr>
-                        <a:t>0.963</a:t>
+                        <a:rPr sz="1100" b="0">
+                          <a:solidFill>
+                            <a:srgbClr val="000000"/>
+                          </a:solidFill>
+                          <a:latin typeface="Arial"/>
+                        </a:rPr>
+                        <a:t>0.962 / 0.963</a:t>
                       </a:r>
                     </a:p>
                   </a:txBody>
@@ -3653,13 +3653,13 @@
                     <a:p>
                       <a:pPr algn="ctr"/>
                       <a:r>
-                        <a:rPr sz="1200" b="0">
-                          <a:solidFill>
-                            <a:srgbClr val="000000"/>
-                          </a:solidFill>
-                          <a:latin typeface="Arial"/>
-                        </a:rPr>
-                        <a:t>0.023</a:t>
+                        <a:rPr sz="1100" b="0">
+                          <a:solidFill>
+                            <a:srgbClr val="000000"/>
+                          </a:solidFill>
+                          <a:latin typeface="Arial"/>
+                        </a:rPr>
+                        <a:t>0.023 / 0.023</a:t>
                       </a:r>
                     </a:p>
                   </a:txBody>
@@ -3688,7 +3688,7 @@
                     <a:p>
                       <a:pPr algn="ctr"/>
                       <a:r>
-                        <a:rPr sz="1200" b="0">
+                        <a:rPr sz="1100" b="0">
                           <a:solidFill>
                             <a:srgbClr val="000000"/>
                           </a:solidFill>
@@ -3723,13 +3723,13 @@
                     <a:p>
                       <a:pPr algn="ctr"/>
                       <a:r>
-                        <a:rPr sz="1200" b="0">
-                          <a:solidFill>
-                            <a:srgbClr val="000000"/>
-                          </a:solidFill>
-                          <a:latin typeface="Arial"/>
-                        </a:rPr>
-                        <a:t>0.912</a:t>
+                        <a:rPr sz="1100" b="0">
+                          <a:solidFill>
+                            <a:srgbClr val="000000"/>
+                          </a:solidFill>
+                          <a:latin typeface="Arial"/>
+                        </a:rPr>
+                        <a:t>0.904 / 0.912</a:t>
                       </a:r>
                     </a:p>
                   </a:txBody>
@@ -3758,13 +3758,13 @@
                     <a:p>
                       <a:pPr algn="ctr"/>
                       <a:r>
-                        <a:rPr sz="1200" b="1">
-                          <a:solidFill>
-                            <a:srgbClr val="000000"/>
-                          </a:solidFill>
-                          <a:latin typeface="Arial"/>
-                        </a:rPr>
-                        <a:t>0.878</a:t>
+                        <a:rPr sz="1100" b="1">
+                          <a:solidFill>
+                            <a:srgbClr val="000000"/>
+                          </a:solidFill>
+                          <a:latin typeface="Arial"/>
+                        </a:rPr>
+                        <a:t>0.870 / 0.878</a:t>
                       </a:r>
                     </a:p>
                   </a:txBody>
@@ -3795,7 +3795,7 @@
                     <a:p>
                       <a:pPr algn="ctr"/>
                       <a:r>
-                        <a:rPr sz="1200" b="0">
+                        <a:rPr sz="1100" b="0">
                           <a:solidFill>
                             <a:srgbClr val="000000"/>
                           </a:solidFill>
@@ -3830,7 +3830,7 @@
                     <a:p>
                       <a:pPr algn="ctr"/>
                       <a:r>
-                        <a:rPr sz="1200" b="0">
+                        <a:rPr sz="1100" b="0">
                           <a:solidFill>
                             <a:srgbClr val="000000"/>
                           </a:solidFill>
@@ -3865,7 +3865,7 @@
                     <a:p>
                       <a:pPr algn="ctr"/>
                       <a:r>
-                        <a:rPr sz="1200" b="0">
+                        <a:rPr sz="1100" b="0">
                           <a:solidFill>
                             <a:srgbClr val="000000"/>
                           </a:solidFill>
@@ -3900,13 +3900,13 @@
                     <a:p>
                       <a:pPr algn="ctr"/>
                       <a:r>
-                        <a:rPr sz="1200" b="0">
-                          <a:solidFill>
-                            <a:srgbClr val="000000"/>
-                          </a:solidFill>
-                          <a:latin typeface="Arial"/>
-                        </a:rPr>
-                        <a:t>0.971</a:t>
+                        <a:rPr sz="1100" b="0">
+                          <a:solidFill>
+                            <a:srgbClr val="000000"/>
+                          </a:solidFill>
+                          <a:latin typeface="Arial"/>
+                        </a:rPr>
+                        <a:t>0.970 / 0.971</a:t>
                       </a:r>
                     </a:p>
                   </a:txBody>
@@ -3935,13 +3935,13 @@
                     <a:p>
                       <a:pPr algn="ctr"/>
                       <a:r>
-                        <a:rPr sz="1200" b="0">
-                          <a:solidFill>
-                            <a:srgbClr val="000000"/>
-                          </a:solidFill>
-                          <a:latin typeface="Arial"/>
-                        </a:rPr>
-                        <a:t>0.015</a:t>
+                        <a:rPr sz="1100" b="0">
+                          <a:solidFill>
+                            <a:srgbClr val="000000"/>
+                          </a:solidFill>
+                          <a:latin typeface="Arial"/>
+                        </a:rPr>
+                        <a:t>0.015 / 0.015</a:t>
                       </a:r>
                     </a:p>
                   </a:txBody>
@@ -3970,7 +3970,7 @@
                     <a:p>
                       <a:pPr algn="ctr"/>
                       <a:r>
-                        <a:rPr sz="1200" b="0">
+                        <a:rPr sz="1100" b="0">
                           <a:solidFill>
                             <a:srgbClr val="000000"/>
                           </a:solidFill>
@@ -4005,13 +4005,13 @@
                     <a:p>
                       <a:pPr algn="ctr"/>
                       <a:r>
-                        <a:rPr sz="1200" b="0">
-                          <a:solidFill>
-                            <a:srgbClr val="000000"/>
-                          </a:solidFill>
-                          <a:latin typeface="Arial"/>
-                        </a:rPr>
-                        <a:t>0.908</a:t>
+                        <a:rPr sz="1100" b="0">
+                          <a:solidFill>
+                            <a:srgbClr val="000000"/>
+                          </a:solidFill>
+                          <a:latin typeface="Arial"/>
+                        </a:rPr>
+                        <a:t>0.900 / 0.908</a:t>
                       </a:r>
                     </a:p>
                   </a:txBody>
@@ -4040,13 +4040,13 @@
                     <a:p>
                       <a:pPr algn="ctr"/>
                       <a:r>
-                        <a:rPr sz="1200" b="1">
-                          <a:solidFill>
-                            <a:srgbClr val="000000"/>
-                          </a:solidFill>
-                          <a:latin typeface="Arial"/>
-                        </a:rPr>
-                        <a:t>0.882</a:t>
+                        <a:rPr sz="1100" b="1">
+                          <a:solidFill>
+                            <a:srgbClr val="000000"/>
+                          </a:solidFill>
+                          <a:latin typeface="Arial"/>
+                        </a:rPr>
+                        <a:t>0.873 / 0.882</a:t>
                       </a:r>
                     </a:p>
                   </a:txBody>
@@ -4077,7 +4077,7 @@
                     <a:p>
                       <a:pPr algn="ctr"/>
                       <a:r>
-                        <a:rPr sz="1200" b="0">
+                        <a:rPr sz="1100" b="0">
                           <a:solidFill>
                             <a:srgbClr val="000000"/>
                           </a:solidFill>
@@ -4114,7 +4114,7 @@
                     <a:p>
                       <a:pPr algn="ctr"/>
                       <a:r>
-                        <a:rPr sz="1200" b="0">
+                        <a:rPr sz="1100" b="0">
                           <a:solidFill>
                             <a:srgbClr val="000000"/>
                           </a:solidFill>
@@ -4151,7 +4151,7 @@
                     <a:p>
                       <a:pPr algn="ctr"/>
                       <a:r>
-                        <a:rPr sz="1200" b="0">
+                        <a:rPr sz="1100" b="0">
                           <a:solidFill>
                             <a:srgbClr val="000000"/>
                           </a:solidFill>
@@ -4188,13 +4188,13 @@
                     <a:p>
                       <a:pPr algn="ctr"/>
                       <a:r>
-                        <a:rPr sz="1200" b="0">
-                          <a:solidFill>
-                            <a:srgbClr val="000000"/>
-                          </a:solidFill>
-                          <a:latin typeface="Arial"/>
-                        </a:rPr>
-                        <a:t>0.976</a:t>
+                        <a:rPr sz="1100" b="0">
+                          <a:solidFill>
+                            <a:srgbClr val="000000"/>
+                          </a:solidFill>
+                          <a:latin typeface="Arial"/>
+                        </a:rPr>
+                        <a:t>0.975 / 0.976</a:t>
                       </a:r>
                     </a:p>
                   </a:txBody>
@@ -4225,13 +4225,13 @@
                     <a:p>
                       <a:pPr algn="ctr"/>
                       <a:r>
-                        <a:rPr sz="1200" b="0">
-                          <a:solidFill>
-                            <a:srgbClr val="000000"/>
-                          </a:solidFill>
-                          <a:latin typeface="Arial"/>
-                        </a:rPr>
-                        <a:t>0.010</a:t>
+                        <a:rPr sz="1100" b="0">
+                          <a:solidFill>
+                            <a:srgbClr val="000000"/>
+                          </a:solidFill>
+                          <a:latin typeface="Arial"/>
+                        </a:rPr>
+                        <a:t>0.010 / 0.010</a:t>
                       </a:r>
                     </a:p>
                   </a:txBody>
@@ -4262,7 +4262,7 @@
                     <a:p>
                       <a:pPr algn="ctr"/>
                       <a:r>
-                        <a:rPr sz="1200" b="0">
+                        <a:rPr sz="1100" b="0">
                           <a:solidFill>
                             <a:srgbClr val="000000"/>
                           </a:solidFill>
@@ -4299,13 +4299,13 @@
                     <a:p>
                       <a:pPr algn="ctr"/>
                       <a:r>
-                        <a:rPr sz="1200" b="0">
-                          <a:solidFill>
-                            <a:srgbClr val="000000"/>
-                          </a:solidFill>
-                          <a:latin typeface="Arial"/>
-                        </a:rPr>
-                        <a:t>0.906</a:t>
+                        <a:rPr sz="1100" b="0">
+                          <a:solidFill>
+                            <a:srgbClr val="000000"/>
+                          </a:solidFill>
+                          <a:latin typeface="Arial"/>
+                        </a:rPr>
+                        <a:t>0.897 / 0.906</a:t>
                       </a:r>
                     </a:p>
                   </a:txBody>
@@ -4336,13 +4336,13 @@
                     <a:p>
                       <a:pPr algn="ctr"/>
                       <a:r>
-                        <a:rPr sz="1200" b="1">
-                          <a:solidFill>
-                            <a:srgbClr val="000000"/>
-                          </a:solidFill>
-                          <a:latin typeface="Arial"/>
-                        </a:rPr>
-                        <a:t>0.884</a:t>
+                        <a:rPr sz="1100" b="1">
+                          <a:solidFill>
+                            <a:srgbClr val="000000"/>
+                          </a:solidFill>
+                          <a:latin typeface="Arial"/>
+                        </a:rPr>
+                        <a:t>0.875 / 0.884</a:t>
                       </a:r>
                     </a:p>
                   </a:txBody>
@@ -4375,7 +4375,7 @@
                     <a:p>
                       <a:pPr algn="ctr"/>
                       <a:r>
-                        <a:rPr sz="1200" b="0">
+                        <a:rPr sz="1100" b="0">
                           <a:solidFill>
                             <a:srgbClr val="000000"/>
                           </a:solidFill>
@@ -4410,7 +4410,7 @@
                     <a:p>
                       <a:pPr algn="ctr"/>
                       <a:r>
-                        <a:rPr sz="1200" b="0">
+                        <a:rPr sz="1100" b="0">
                           <a:solidFill>
                             <a:srgbClr val="000000"/>
                           </a:solidFill>
@@ -4445,7 +4445,7 @@
                     <a:p>
                       <a:pPr algn="ctr"/>
                       <a:r>
-                        <a:rPr sz="1200" b="0">
+                        <a:rPr sz="1100" b="0">
                           <a:solidFill>
                             <a:srgbClr val="000000"/>
                           </a:solidFill>
@@ -4480,13 +4480,13 @@
                     <a:p>
                       <a:pPr algn="ctr"/>
                       <a:r>
-                        <a:rPr sz="1200" b="0">
-                          <a:solidFill>
-                            <a:srgbClr val="000000"/>
-                          </a:solidFill>
-                          <a:latin typeface="Arial"/>
-                        </a:rPr>
-                        <a:t>0.966</a:t>
+                        <a:rPr sz="1100" b="0">
+                          <a:solidFill>
+                            <a:srgbClr val="000000"/>
+                          </a:solidFill>
+                          <a:latin typeface="Arial"/>
+                        </a:rPr>
+                        <a:t>0.965 / 0.966</a:t>
                       </a:r>
                     </a:p>
                   </a:txBody>
@@ -4515,13 +4515,13 @@
                     <a:p>
                       <a:pPr algn="ctr"/>
                       <a:r>
-                        <a:rPr sz="1200" b="0">
-                          <a:solidFill>
-                            <a:srgbClr val="000000"/>
-                          </a:solidFill>
-                          <a:latin typeface="Arial"/>
-                        </a:rPr>
-                        <a:t>0.023</a:t>
+                        <a:rPr sz="1100" b="0">
+                          <a:solidFill>
+                            <a:srgbClr val="000000"/>
+                          </a:solidFill>
+                          <a:latin typeface="Arial"/>
+                        </a:rPr>
+                        <a:t>0.023 / 0.023</a:t>
                       </a:r>
                     </a:p>
                   </a:txBody>
@@ -4550,7 +4550,7 @@
                     <a:p>
                       <a:pPr algn="ctr"/>
                       <a:r>
-                        <a:rPr sz="1200" b="0">
+                        <a:rPr sz="1100" b="0">
                           <a:solidFill>
                             <a:srgbClr val="000000"/>
                           </a:solidFill>
@@ -4585,13 +4585,13 @@
                     <a:p>
                       <a:pPr algn="ctr"/>
                       <a:r>
-                        <a:rPr sz="1200" b="0">
-                          <a:solidFill>
-                            <a:srgbClr val="000000"/>
-                          </a:solidFill>
-                          <a:latin typeface="Arial"/>
-                        </a:rPr>
-                        <a:t>0.929</a:t>
+                        <a:rPr sz="1100" b="0">
+                          <a:solidFill>
+                            <a:srgbClr val="000000"/>
+                          </a:solidFill>
+                          <a:latin typeface="Arial"/>
+                        </a:rPr>
+                        <a:t>0.921 / 0.929</a:t>
                       </a:r>
                     </a:p>
                   </a:txBody>
@@ -4620,13 +4620,13 @@
                     <a:p>
                       <a:pPr algn="ctr"/>
                       <a:r>
-                        <a:rPr sz="1200" b="1">
-                          <a:solidFill>
-                            <a:srgbClr val="000000"/>
-                          </a:solidFill>
-                          <a:latin typeface="Arial"/>
-                        </a:rPr>
-                        <a:t>0.897</a:t>
+                        <a:rPr sz="1100" b="1">
+                          <a:solidFill>
+                            <a:srgbClr val="000000"/>
+                          </a:solidFill>
+                          <a:latin typeface="Arial"/>
+                        </a:rPr>
+                        <a:t>0.889 / 0.897</a:t>
                       </a:r>
                     </a:p>
                   </a:txBody>
@@ -4657,7 +4657,7 @@
                     <a:p>
                       <a:pPr algn="ctr"/>
                       <a:r>
-                        <a:rPr sz="1200" b="0">
+                        <a:rPr sz="1100" b="0">
                           <a:solidFill>
                             <a:srgbClr val="000000"/>
                           </a:solidFill>
@@ -4692,7 +4692,7 @@
                     <a:p>
                       <a:pPr algn="ctr"/>
                       <a:r>
-                        <a:rPr sz="1200" b="0">
+                        <a:rPr sz="1100" b="0">
                           <a:solidFill>
                             <a:srgbClr val="000000"/>
                           </a:solidFill>
@@ -4727,7 +4727,7 @@
                     <a:p>
                       <a:pPr algn="ctr"/>
                       <a:r>
-                        <a:rPr sz="1200" b="0">
+                        <a:rPr sz="1100" b="0">
                           <a:solidFill>
                             <a:srgbClr val="000000"/>
                           </a:solidFill>
@@ -4762,13 +4762,13 @@
                     <a:p>
                       <a:pPr algn="ctr"/>
                       <a:r>
-                        <a:rPr sz="1200" b="0">
-                          <a:solidFill>
-                            <a:srgbClr val="000000"/>
-                          </a:solidFill>
-                          <a:latin typeface="Arial"/>
-                        </a:rPr>
-                        <a:t>0.973</a:t>
+                        <a:rPr sz="1100" b="0">
+                          <a:solidFill>
+                            <a:srgbClr val="000000"/>
+                          </a:solidFill>
+                          <a:latin typeface="Arial"/>
+                        </a:rPr>
+                        <a:t>0.973 / 0.973</a:t>
                       </a:r>
                     </a:p>
                   </a:txBody>
@@ -4797,13 +4797,13 @@
                     <a:p>
                       <a:pPr algn="ctr"/>
                       <a:r>
-                        <a:rPr sz="1200" b="0">
-                          <a:solidFill>
-                            <a:srgbClr val="000000"/>
-                          </a:solidFill>
-                          <a:latin typeface="Arial"/>
-                        </a:rPr>
-                        <a:t>0.015</a:t>
+                        <a:rPr sz="1100" b="0">
+                          <a:solidFill>
+                            <a:srgbClr val="000000"/>
+                          </a:solidFill>
+                          <a:latin typeface="Arial"/>
+                        </a:rPr>
+                        <a:t>0.015 / 0.015</a:t>
                       </a:r>
                     </a:p>
                   </a:txBody>
@@ -4832,7 +4832,7 @@
                     <a:p>
                       <a:pPr algn="ctr"/>
                       <a:r>
-                        <a:rPr sz="1200" b="0">
+                        <a:rPr sz="1100" b="0">
                           <a:solidFill>
                             <a:srgbClr val="000000"/>
                           </a:solidFill>
@@ -4867,13 +4867,13 @@
                     <a:p>
                       <a:pPr algn="ctr"/>
                       <a:r>
-                        <a:rPr sz="1200" b="0">
-                          <a:solidFill>
-                            <a:srgbClr val="000000"/>
-                          </a:solidFill>
-                          <a:latin typeface="Arial"/>
-                        </a:rPr>
-                        <a:t>0.926</a:t>
+                        <a:rPr sz="1100" b="0">
+                          <a:solidFill>
+                            <a:srgbClr val="000000"/>
+                          </a:solidFill>
+                          <a:latin typeface="Arial"/>
+                        </a:rPr>
+                        <a:t>0.918 / 0.926</a:t>
                       </a:r>
                     </a:p>
                   </a:txBody>
@@ -4902,13 +4902,13 @@
                     <a:p>
                       <a:pPr algn="ctr"/>
                       <a:r>
-                        <a:rPr sz="1200" b="1">
-                          <a:solidFill>
-                            <a:srgbClr val="000000"/>
-                          </a:solidFill>
-                          <a:latin typeface="Arial"/>
-                        </a:rPr>
-                        <a:t>0.902</a:t>
+                        <a:rPr sz="1100" b="1">
+                          <a:solidFill>
+                            <a:srgbClr val="000000"/>
+                          </a:solidFill>
+                          <a:latin typeface="Arial"/>
+                        </a:rPr>
+                        <a:t>0.893 / 0.902</a:t>
                       </a:r>
                     </a:p>
                   </a:txBody>
@@ -4939,7 +4939,7 @@
                     <a:p>
                       <a:pPr algn="ctr"/>
                       <a:r>
-                        <a:rPr sz="1200" b="0">
+                        <a:rPr sz="1100" b="0">
                           <a:solidFill>
                             <a:srgbClr val="000000"/>
                           </a:solidFill>
@@ -4976,7 +4976,7 @@
                     <a:p>
                       <a:pPr algn="ctr"/>
                       <a:r>
-                        <a:rPr sz="1200" b="0">
+                        <a:rPr sz="1100" b="0">
                           <a:solidFill>
                             <a:srgbClr val="000000"/>
                           </a:solidFill>
@@ -5013,7 +5013,7 @@
                     <a:p>
                       <a:pPr algn="ctr"/>
                       <a:r>
-                        <a:rPr sz="1200" b="0">
+                        <a:rPr sz="1100" b="0">
                           <a:solidFill>
                             <a:srgbClr val="000000"/>
                           </a:solidFill>
@@ -5050,13 +5050,13 @@
                     <a:p>
                       <a:pPr algn="ctr"/>
                       <a:r>
-                        <a:rPr sz="1200" b="0">
-                          <a:solidFill>
-                            <a:srgbClr val="000000"/>
-                          </a:solidFill>
-                          <a:latin typeface="Arial"/>
-                        </a:rPr>
-                        <a:t>0.979</a:t>
+                        <a:rPr sz="1100" b="0">
+                          <a:solidFill>
+                            <a:srgbClr val="000000"/>
+                          </a:solidFill>
+                          <a:latin typeface="Arial"/>
+                        </a:rPr>
+                        <a:t>0.978 / 0.979</a:t>
                       </a:r>
                     </a:p>
                   </a:txBody>
@@ -5087,13 +5087,13 @@
                     <a:p>
                       <a:pPr algn="ctr"/>
                       <a:r>
-                        <a:rPr sz="1200" b="0">
-                          <a:solidFill>
-                            <a:srgbClr val="000000"/>
-                          </a:solidFill>
-                          <a:latin typeface="Arial"/>
-                        </a:rPr>
-                        <a:t>0.010</a:t>
+                        <a:rPr sz="1100" b="0">
+                          <a:solidFill>
+                            <a:srgbClr val="000000"/>
+                          </a:solidFill>
+                          <a:latin typeface="Arial"/>
+                        </a:rPr>
+                        <a:t>0.010 / 0.010</a:t>
                       </a:r>
                     </a:p>
                   </a:txBody>
@@ -5124,7 +5124,7 @@
                     <a:p>
                       <a:pPr algn="ctr"/>
                       <a:r>
-                        <a:rPr sz="1200" b="0">
+                        <a:rPr sz="1100" b="0">
                           <a:solidFill>
                             <a:srgbClr val="000000"/>
                           </a:solidFill>
@@ -5161,13 +5161,13 @@
                     <a:p>
                       <a:pPr algn="ctr"/>
                       <a:r>
-                        <a:rPr sz="1200" b="0">
-                          <a:solidFill>
-                            <a:srgbClr val="000000"/>
-                          </a:solidFill>
-                          <a:latin typeface="Arial"/>
-                        </a:rPr>
-                        <a:t>0.924</a:t>
+                        <a:rPr sz="1100" b="0">
+                          <a:solidFill>
+                            <a:srgbClr val="000000"/>
+                          </a:solidFill>
+                          <a:latin typeface="Arial"/>
+                        </a:rPr>
+                        <a:t>0.916 / 0.924</a:t>
                       </a:r>
                     </a:p>
                   </a:txBody>
@@ -5198,13 +5198,13 @@
                     <a:p>
                       <a:pPr algn="ctr"/>
                       <a:r>
-                        <a:rPr sz="1200" b="1">
-                          <a:solidFill>
-                            <a:srgbClr val="000000"/>
-                          </a:solidFill>
-                          <a:latin typeface="Arial"/>
-                        </a:rPr>
-                        <a:t>0.905</a:t>
+                        <a:rPr sz="1100" b="1">
+                          <a:solidFill>
+                            <a:srgbClr val="000000"/>
+                          </a:solidFill>
+                          <a:latin typeface="Arial"/>
+                        </a:rPr>
+                        <a:t>0.896 / 0.905</a:t>
                       </a:r>
                     </a:p>
                   </a:txBody>
@@ -5237,7 +5237,7 @@
                     <a:p>
                       <a:pPr algn="ctr"/>
                       <a:r>
-                        <a:rPr sz="1200" b="0">
+                        <a:rPr sz="1100" b="0">
                           <a:solidFill>
                             <a:srgbClr val="000000"/>
                           </a:solidFill>
@@ -5272,7 +5272,7 @@
                     <a:p>
                       <a:pPr algn="ctr"/>
                       <a:r>
-                        <a:rPr sz="1200" b="0">
+                        <a:rPr sz="1100" b="0">
                           <a:solidFill>
                             <a:srgbClr val="000000"/>
                           </a:solidFill>
@@ -5307,7 +5307,7 @@
                     <a:p>
                       <a:pPr algn="ctr"/>
                       <a:r>
-                        <a:rPr sz="1200" b="0">
+                        <a:rPr sz="1100" b="0">
                           <a:solidFill>
                             <a:srgbClr val="000000"/>
                           </a:solidFill>
@@ -5342,13 +5342,13 @@
                     <a:p>
                       <a:pPr algn="ctr"/>
                       <a:r>
-                        <a:rPr sz="1200" b="0">
-                          <a:solidFill>
-                            <a:srgbClr val="000000"/>
-                          </a:solidFill>
-                          <a:latin typeface="Arial"/>
-                        </a:rPr>
-                        <a:t>0.981</a:t>
+                        <a:rPr sz="1100" b="0">
+                          <a:solidFill>
+                            <a:srgbClr val="000000"/>
+                          </a:solidFill>
+                          <a:latin typeface="Arial"/>
+                        </a:rPr>
+                        <a:t>0.979 / 0.981</a:t>
                       </a:r>
                     </a:p>
                   </a:txBody>
@@ -5377,13 +5377,13 @@
                     <a:p>
                       <a:pPr algn="ctr"/>
                       <a:r>
-                        <a:rPr sz="1200" b="0">
-                          <a:solidFill>
-                            <a:srgbClr val="000000"/>
-                          </a:solidFill>
-                          <a:latin typeface="Arial"/>
-                        </a:rPr>
-                        <a:t>0.003</a:t>
+                        <a:rPr sz="1100" b="0">
+                          <a:solidFill>
+                            <a:srgbClr val="000000"/>
+                          </a:solidFill>
+                          <a:latin typeface="Arial"/>
+                        </a:rPr>
+                        <a:t>0.004 / 0.003</a:t>
                       </a:r>
                     </a:p>
                   </a:txBody>
@@ -5412,7 +5412,7 @@
                     <a:p>
                       <a:pPr algn="ctr"/>
                       <a:r>
-                        <a:rPr sz="1200" b="0">
+                        <a:rPr sz="1100" b="0">
                           <a:solidFill>
                             <a:srgbClr val="000000"/>
                           </a:solidFill>
@@ -5447,13 +5447,13 @@
                     <a:p>
                       <a:pPr algn="ctr"/>
                       <a:r>
-                        <a:rPr sz="1200" b="0">
-                          <a:solidFill>
-                            <a:srgbClr val="000000"/>
-                          </a:solidFill>
-                          <a:latin typeface="Arial"/>
-                        </a:rPr>
-                        <a:t>0.907</a:t>
+                        <a:rPr sz="1100" b="0">
+                          <a:solidFill>
+                            <a:srgbClr val="000000"/>
+                          </a:solidFill>
+                          <a:latin typeface="Arial"/>
+                        </a:rPr>
+                        <a:t>0.901 / 0.907</a:t>
                       </a:r>
                     </a:p>
                   </a:txBody>
@@ -5482,13 +5482,13 @@
                     <a:p>
                       <a:pPr algn="ctr"/>
                       <a:r>
-                        <a:rPr sz="1200" b="1">
-                          <a:solidFill>
-                            <a:srgbClr val="000000"/>
-                          </a:solidFill>
-                          <a:latin typeface="Arial"/>
-                        </a:rPr>
-                        <a:t>0.890</a:t>
+                        <a:rPr sz="1100" b="1">
+                          <a:solidFill>
+                            <a:srgbClr val="000000"/>
+                          </a:solidFill>
+                          <a:latin typeface="Arial"/>
+                        </a:rPr>
+                        <a:t>0.883 / 0.890</a:t>
                       </a:r>
                     </a:p>
                   </a:txBody>
@@ -5519,7 +5519,7 @@
                     <a:p>
                       <a:pPr algn="ctr"/>
                       <a:r>
-                        <a:rPr sz="1200" b="0">
+                        <a:rPr sz="1100" b="0">
                           <a:solidFill>
                             <a:srgbClr val="000000"/>
                           </a:solidFill>
@@ -5554,7 +5554,7 @@
                     <a:p>
                       <a:pPr algn="ctr"/>
                       <a:r>
-                        <a:rPr sz="1200" b="0">
+                        <a:rPr sz="1100" b="0">
                           <a:solidFill>
                             <a:srgbClr val="000000"/>
                           </a:solidFill>
@@ -5589,7 +5589,7 @@
                     <a:p>
                       <a:pPr algn="ctr"/>
                       <a:r>
-                        <a:rPr sz="1200" b="0">
+                        <a:rPr sz="1100" b="0">
                           <a:solidFill>
                             <a:srgbClr val="000000"/>
                           </a:solidFill>
@@ -5624,13 +5624,13 @@
                     <a:p>
                       <a:pPr algn="ctr"/>
                       <a:r>
-                        <a:rPr sz="1200" b="0">
-                          <a:solidFill>
-                            <a:srgbClr val="000000"/>
-                          </a:solidFill>
-                          <a:latin typeface="Arial"/>
-                        </a:rPr>
-                        <a:t>0.981</a:t>
+                        <a:rPr sz="1100" b="0">
+                          <a:solidFill>
+                            <a:srgbClr val="000000"/>
+                          </a:solidFill>
+                          <a:latin typeface="Arial"/>
+                        </a:rPr>
+                        <a:t>0.980 / 0.981</a:t>
                       </a:r>
                     </a:p>
                   </a:txBody>
@@ -5659,13 +5659,13 @@
                     <a:p>
                       <a:pPr algn="ctr"/>
                       <a:r>
-                        <a:rPr sz="1200" b="0">
-                          <a:solidFill>
-                            <a:srgbClr val="000000"/>
-                          </a:solidFill>
-                          <a:latin typeface="Arial"/>
-                        </a:rPr>
-                        <a:t>0.002</a:t>
+                        <a:rPr sz="1100" b="0">
+                          <a:solidFill>
+                            <a:srgbClr val="000000"/>
+                          </a:solidFill>
+                          <a:latin typeface="Arial"/>
+                        </a:rPr>
+                        <a:t>0.003 / 0.002</a:t>
                       </a:r>
                     </a:p>
                   </a:txBody>
@@ -5694,7 +5694,7 @@
                     <a:p>
                       <a:pPr algn="ctr"/>
                       <a:r>
-                        <a:rPr sz="1200" b="0">
+                        <a:rPr sz="1100" b="0">
                           <a:solidFill>
                             <a:srgbClr val="000000"/>
                           </a:solidFill>
@@ -5729,13 +5729,13 @@
                     <a:p>
                       <a:pPr algn="ctr"/>
                       <a:r>
-                        <a:rPr sz="1200" b="0">
-                          <a:solidFill>
-                            <a:srgbClr val="000000"/>
-                          </a:solidFill>
-                          <a:latin typeface="Arial"/>
-                        </a:rPr>
-                        <a:t>0.903</a:t>
+                        <a:rPr sz="1100" b="0">
+                          <a:solidFill>
+                            <a:srgbClr val="000000"/>
+                          </a:solidFill>
+                          <a:latin typeface="Arial"/>
+                        </a:rPr>
+                        <a:t>0.896 / 0.903</a:t>
                       </a:r>
                     </a:p>
                   </a:txBody>
@@ -5764,13 +5764,13 @@
                     <a:p>
                       <a:pPr algn="ctr"/>
                       <a:r>
-                        <a:rPr sz="1200" b="1">
-                          <a:solidFill>
-                            <a:srgbClr val="000000"/>
-                          </a:solidFill>
-                          <a:latin typeface="Arial"/>
-                        </a:rPr>
-                        <a:t>0.886</a:t>
+                        <a:rPr sz="1100" b="1">
+                          <a:solidFill>
+                            <a:srgbClr val="000000"/>
+                          </a:solidFill>
+                          <a:latin typeface="Arial"/>
+                        </a:rPr>
+                        <a:t>0.879 / 0.886</a:t>
                       </a:r>
                     </a:p>
                   </a:txBody>
@@ -5801,7 +5801,7 @@
                     <a:p>
                       <a:pPr algn="ctr"/>
                       <a:r>
-                        <a:rPr sz="1200" b="0">
+                        <a:rPr sz="1100" b="0">
                           <a:solidFill>
                             <a:srgbClr val="000000"/>
                           </a:solidFill>
@@ -5838,7 +5838,7 @@
                     <a:p>
                       <a:pPr algn="ctr"/>
                       <a:r>
-                        <a:rPr sz="1200" b="0">
+                        <a:rPr sz="1100" b="0">
                           <a:solidFill>
                             <a:srgbClr val="000000"/>
                           </a:solidFill>
@@ -5875,7 +5875,7 @@
                     <a:p>
                       <a:pPr algn="ctr"/>
                       <a:r>
-                        <a:rPr sz="1200" b="0">
+                        <a:rPr sz="1100" b="0">
                           <a:solidFill>
                             <a:srgbClr val="000000"/>
                           </a:solidFill>
@@ -5912,13 +5912,13 @@
                     <a:p>
                       <a:pPr algn="ctr"/>
                       <a:r>
-                        <a:rPr sz="1200" b="0">
-                          <a:solidFill>
-                            <a:srgbClr val="000000"/>
-                          </a:solidFill>
-                          <a:latin typeface="Arial"/>
-                        </a:rPr>
-                        <a:t>0.982</a:t>
+                        <a:rPr sz="1100" b="0">
+                          <a:solidFill>
+                            <a:srgbClr val="000000"/>
+                          </a:solidFill>
+                          <a:latin typeface="Arial"/>
+                        </a:rPr>
+                        <a:t>0.981 / 0.982</a:t>
                       </a:r>
                     </a:p>
                   </a:txBody>
@@ -5949,13 +5949,13 @@
                     <a:p>
                       <a:pPr algn="ctr"/>
                       <a:r>
-                        <a:rPr sz="1200" b="0">
-                          <a:solidFill>
-                            <a:srgbClr val="000000"/>
-                          </a:solidFill>
-                          <a:latin typeface="Arial"/>
-                        </a:rPr>
-                        <a:t>0.001</a:t>
+                        <a:rPr sz="1100" b="0">
+                          <a:solidFill>
+                            <a:srgbClr val="000000"/>
+                          </a:solidFill>
+                          <a:latin typeface="Arial"/>
+                        </a:rPr>
+                        <a:t>0.002 / 0.001</a:t>
                       </a:r>
                     </a:p>
                   </a:txBody>
@@ -5986,7 +5986,7 @@
                     <a:p>
                       <a:pPr algn="ctr"/>
                       <a:r>
-                        <a:rPr sz="1200" b="0">
+                        <a:rPr sz="1100" b="0">
                           <a:solidFill>
                             <a:srgbClr val="000000"/>
                           </a:solidFill>
@@ -6023,13 +6023,13 @@
                     <a:p>
                       <a:pPr algn="ctr"/>
                       <a:r>
-                        <a:rPr sz="1200" b="0">
-                          <a:solidFill>
-                            <a:srgbClr val="000000"/>
-                          </a:solidFill>
-                          <a:latin typeface="Arial"/>
-                        </a:rPr>
-                        <a:t>0.900</a:t>
+                        <a:rPr sz="1100" b="0">
+                          <a:solidFill>
+                            <a:srgbClr val="000000"/>
+                          </a:solidFill>
+                          <a:latin typeface="Arial"/>
+                        </a:rPr>
+                        <a:t>0.893 / 0.900</a:t>
                       </a:r>
                     </a:p>
                   </a:txBody>
@@ -6060,13 +6060,13 @@
                     <a:p>
                       <a:pPr algn="ctr"/>
                       <a:r>
-                        <a:rPr sz="1200" b="1">
-                          <a:solidFill>
-                            <a:srgbClr val="000000"/>
-                          </a:solidFill>
-                          <a:latin typeface="Arial"/>
-                        </a:rPr>
-                        <a:t>0.883</a:t>
+                        <a:rPr sz="1100" b="1">
+                          <a:solidFill>
+                            <a:srgbClr val="000000"/>
+                          </a:solidFill>
+                          <a:latin typeface="Arial"/>
+                        </a:rPr>
+                        <a:t>0.876 / 0.883</a:t>
                       </a:r>
                     </a:p>
                   </a:txBody>
@@ -6099,7 +6099,7 @@
                     <a:p>
                       <a:pPr algn="ctr"/>
                       <a:r>
-                        <a:rPr sz="1200" b="0">
+                        <a:rPr sz="1100" b="0">
                           <a:solidFill>
                             <a:srgbClr val="000000"/>
                           </a:solidFill>
@@ -6134,7 +6134,7 @@
                     <a:p>
                       <a:pPr algn="ctr"/>
                       <a:r>
-                        <a:rPr sz="1200" b="0">
+                        <a:rPr sz="1100" b="0">
                           <a:solidFill>
                             <a:srgbClr val="000000"/>
                           </a:solidFill>
@@ -6169,7 +6169,7 @@
                     <a:p>
                       <a:pPr algn="ctr"/>
                       <a:r>
-                        <a:rPr sz="1200" b="0">
+                        <a:rPr sz="1100" b="0">
                           <a:solidFill>
                             <a:srgbClr val="000000"/>
                           </a:solidFill>
@@ -6204,13 +6204,13 @@
                     <a:p>
                       <a:pPr algn="ctr"/>
                       <a:r>
-                        <a:rPr sz="1200" b="0">
-                          <a:solidFill>
-                            <a:srgbClr val="000000"/>
-                          </a:solidFill>
-                          <a:latin typeface="Arial"/>
-                        </a:rPr>
-                        <a:t>0.984</a:t>
+                        <a:rPr sz="1100" b="0">
+                          <a:solidFill>
+                            <a:srgbClr val="000000"/>
+                          </a:solidFill>
+                          <a:latin typeface="Arial"/>
+                        </a:rPr>
+                        <a:t>0.983 / 0.984</a:t>
                       </a:r>
                     </a:p>
                   </a:txBody>
@@ -6239,13 +6239,13 @@
                     <a:p>
                       <a:pPr algn="ctr"/>
                       <a:r>
-                        <a:rPr sz="1200" b="0">
-                          <a:solidFill>
-                            <a:srgbClr val="000000"/>
-                          </a:solidFill>
-                          <a:latin typeface="Arial"/>
-                        </a:rPr>
-                        <a:t>0.003</a:t>
+                        <a:rPr sz="1100" b="0">
+                          <a:solidFill>
+                            <a:srgbClr val="000000"/>
+                          </a:solidFill>
+                          <a:latin typeface="Arial"/>
+                        </a:rPr>
+                        <a:t>0.004 / 0.003</a:t>
                       </a:r>
                     </a:p>
                   </a:txBody>
@@ -6274,7 +6274,7 @@
                     <a:p>
                       <a:pPr algn="ctr"/>
                       <a:r>
-                        <a:rPr sz="1200" b="0">
+                        <a:rPr sz="1100" b="0">
                           <a:solidFill>
                             <a:srgbClr val="000000"/>
                           </a:solidFill>
@@ -6309,13 +6309,13 @@
                     <a:p>
                       <a:pPr algn="ctr"/>
                       <a:r>
-                        <a:rPr sz="1200" b="0">
-                          <a:solidFill>
-                            <a:srgbClr val="000000"/>
-                          </a:solidFill>
-                          <a:latin typeface="Arial"/>
-                        </a:rPr>
-                        <a:t>0.927</a:t>
+                        <a:rPr sz="1100" b="0">
+                          <a:solidFill>
+                            <a:srgbClr val="000000"/>
+                          </a:solidFill>
+                          <a:latin typeface="Arial"/>
+                        </a:rPr>
+                        <a:t>0.921 / 0.927</a:t>
                       </a:r>
                     </a:p>
                   </a:txBody>
@@ -6344,13 +6344,13 @@
                     <a:p>
                       <a:pPr algn="ctr"/>
                       <a:r>
-                        <a:rPr sz="1200" b="1">
-                          <a:solidFill>
-                            <a:srgbClr val="000000"/>
-                          </a:solidFill>
-                          <a:latin typeface="Arial"/>
-                        </a:rPr>
-                        <a:t>0.912</a:t>
+                        <a:rPr sz="1100" b="1">
+                          <a:solidFill>
+                            <a:srgbClr val="000000"/>
+                          </a:solidFill>
+                          <a:latin typeface="Arial"/>
+                        </a:rPr>
+                        <a:t>0.905 / 0.912</a:t>
                       </a:r>
                     </a:p>
                   </a:txBody>
@@ -6381,7 +6381,7 @@
                     <a:p>
                       <a:pPr algn="ctr"/>
                       <a:r>
-                        <a:rPr sz="1200" b="0">
+                        <a:rPr sz="1100" b="0">
                           <a:solidFill>
                             <a:srgbClr val="000000"/>
                           </a:solidFill>
@@ -6416,7 +6416,7 @@
                     <a:p>
                       <a:pPr algn="ctr"/>
                       <a:r>
-                        <a:rPr sz="1200" b="0">
+                        <a:rPr sz="1100" b="0">
                           <a:solidFill>
                             <a:srgbClr val="000000"/>
                           </a:solidFill>
@@ -6451,7 +6451,7 @@
                     <a:p>
                       <a:pPr algn="ctr"/>
                       <a:r>
-                        <a:rPr sz="1200" b="0">
+                        <a:rPr sz="1100" b="0">
                           <a:solidFill>
                             <a:srgbClr val="000000"/>
                           </a:solidFill>
@@ -6486,13 +6486,13 @@
                     <a:p>
                       <a:pPr algn="ctr"/>
                       <a:r>
-                        <a:rPr sz="1200" b="0">
-                          <a:solidFill>
-                            <a:srgbClr val="000000"/>
-                          </a:solidFill>
-                          <a:latin typeface="Arial"/>
-                        </a:rPr>
-                        <a:t>0.984</a:t>
+                        <a:rPr sz="1100" b="0">
+                          <a:solidFill>
+                            <a:srgbClr val="000000"/>
+                          </a:solidFill>
+                          <a:latin typeface="Arial"/>
+                        </a:rPr>
+                        <a:t>0.984 / 0.984</a:t>
                       </a:r>
                     </a:p>
                   </a:txBody>
@@ -6521,13 +6521,13 @@
                     <a:p>
                       <a:pPr algn="ctr"/>
                       <a:r>
-                        <a:rPr sz="1200" b="0">
-                          <a:solidFill>
-                            <a:srgbClr val="000000"/>
-                          </a:solidFill>
-                          <a:latin typeface="Arial"/>
-                        </a:rPr>
-                        <a:t>0.002</a:t>
+                        <a:rPr sz="1100" b="0">
+                          <a:solidFill>
+                            <a:srgbClr val="000000"/>
+                          </a:solidFill>
+                          <a:latin typeface="Arial"/>
+                        </a:rPr>
+                        <a:t>0.003 / 0.002</a:t>
                       </a:r>
                     </a:p>
                   </a:txBody>
@@ -6556,7 +6556,7 @@
                     <a:p>
                       <a:pPr algn="ctr"/>
                       <a:r>
-                        <a:rPr sz="1200" b="0">
+                        <a:rPr sz="1100" b="0">
                           <a:solidFill>
                             <a:srgbClr val="000000"/>
                           </a:solidFill>
@@ -6591,13 +6591,13 @@
                     <a:p>
                       <a:pPr algn="ctr"/>
                       <a:r>
-                        <a:rPr sz="1200" b="0">
-                          <a:solidFill>
-                            <a:srgbClr val="000000"/>
-                          </a:solidFill>
-                          <a:latin typeface="Arial"/>
-                        </a:rPr>
-                        <a:t>0.924</a:t>
+                        <a:rPr sz="1100" b="0">
+                          <a:solidFill>
+                            <a:srgbClr val="000000"/>
+                          </a:solidFill>
+                          <a:latin typeface="Arial"/>
+                        </a:rPr>
+                        <a:t>0.918 / 0.924</a:t>
                       </a:r>
                     </a:p>
                   </a:txBody>
@@ -6626,13 +6626,13 @@
                     <a:p>
                       <a:pPr algn="ctr"/>
                       <a:r>
-                        <a:rPr sz="1200" b="1">
-                          <a:solidFill>
-                            <a:srgbClr val="000000"/>
-                          </a:solidFill>
-                          <a:latin typeface="Arial"/>
-                        </a:rPr>
-                        <a:t>0.909</a:t>
+                        <a:rPr sz="1100" b="1">
+                          <a:solidFill>
+                            <a:srgbClr val="000000"/>
+                          </a:solidFill>
+                          <a:latin typeface="Arial"/>
+                        </a:rPr>
+                        <a:t>0.903 / 0.909</a:t>
                       </a:r>
                     </a:p>
                   </a:txBody>
@@ -6663,7 +6663,7 @@
                     <a:p>
                       <a:pPr algn="ctr"/>
                       <a:r>
-                        <a:rPr sz="1200" b="0">
+                        <a:rPr sz="1100" b="0">
                           <a:solidFill>
                             <a:srgbClr val="000000"/>
                           </a:solidFill>
@@ -6700,7 +6700,7 @@
                     <a:p>
                       <a:pPr algn="ctr"/>
                       <a:r>
-                        <a:rPr sz="1200" b="0">
+                        <a:rPr sz="1100" b="0">
                           <a:solidFill>
                             <a:srgbClr val="000000"/>
                           </a:solidFill>
@@ -6737,7 +6737,7 @@
                     <a:p>
                       <a:pPr algn="ctr"/>
                       <a:r>
-                        <a:rPr sz="1200" b="0">
+                        <a:rPr sz="1100" b="0">
                           <a:solidFill>
                             <a:srgbClr val="000000"/>
                           </a:solidFill>
@@ -6774,13 +6774,13 @@
                     <a:p>
                       <a:pPr algn="ctr"/>
                       <a:r>
-                        <a:rPr sz="1200" b="0">
-                          <a:solidFill>
-                            <a:srgbClr val="000000"/>
-                          </a:solidFill>
-                          <a:latin typeface="Arial"/>
-                        </a:rPr>
-                        <a:t>0.985</a:t>
+                        <a:rPr sz="1100" b="0">
+                          <a:solidFill>
+                            <a:srgbClr val="000000"/>
+                          </a:solidFill>
+                          <a:latin typeface="Arial"/>
+                        </a:rPr>
+                        <a:t>0.984 / 0.985</a:t>
                       </a:r>
                     </a:p>
                   </a:txBody>
@@ -6811,13 +6811,13 @@
                     <a:p>
                       <a:pPr algn="ctr"/>
                       <a:r>
-                        <a:rPr sz="1200" b="0">
-                          <a:solidFill>
-                            <a:srgbClr val="000000"/>
-                          </a:solidFill>
-                          <a:latin typeface="Arial"/>
-                        </a:rPr>
-                        <a:t>0.001</a:t>
+                        <a:rPr sz="1100" b="0">
+                          <a:solidFill>
+                            <a:srgbClr val="000000"/>
+                          </a:solidFill>
+                          <a:latin typeface="Arial"/>
+                        </a:rPr>
+                        <a:t>0.002 / 0.001</a:t>
                       </a:r>
                     </a:p>
                   </a:txBody>
@@ -6848,7 +6848,7 @@
                     <a:p>
                       <a:pPr algn="ctr"/>
                       <a:r>
-                        <a:rPr sz="1200" b="0">
+                        <a:rPr sz="1100" b="0">
                           <a:solidFill>
                             <a:srgbClr val="000000"/>
                           </a:solidFill>
@@ -6885,13 +6885,13 @@
                     <a:p>
                       <a:pPr algn="ctr"/>
                       <a:r>
-                        <a:rPr sz="1200" b="0">
-                          <a:solidFill>
-                            <a:srgbClr val="000000"/>
-                          </a:solidFill>
-                          <a:latin typeface="Arial"/>
-                        </a:rPr>
-                        <a:t>0.921</a:t>
+                        <a:rPr sz="1100" b="0">
+                          <a:solidFill>
+                            <a:srgbClr val="000000"/>
+                          </a:solidFill>
+                          <a:latin typeface="Arial"/>
+                        </a:rPr>
+                        <a:t>0.915 / 0.921</a:t>
                       </a:r>
                     </a:p>
                   </a:txBody>
@@ -6922,13 +6922,13 @@
                     <a:p>
                       <a:pPr algn="ctr"/>
                       <a:r>
-                        <a:rPr sz="1200" b="1">
-                          <a:solidFill>
-                            <a:srgbClr val="000000"/>
-                          </a:solidFill>
-                          <a:latin typeface="Arial"/>
-                        </a:rPr>
-                        <a:t>0.907</a:t>
+                        <a:rPr sz="1100" b="1">
+                          <a:solidFill>
+                            <a:srgbClr val="000000"/>
+                          </a:solidFill>
+                          <a:latin typeface="Arial"/>
+                        </a:rPr>
+                        <a:t>0.901 / 0.907</a:t>
                       </a:r>
                     </a:p>
                   </a:txBody>

</xml_diff>